<commit_message>
Presentation: add SAR cover and Thank You closing slide
Co-Authored-By: Claude Sonnet 5.5 <noreply@anthropic.com>
Claude-Session: https://claude.ai/code/session_01DZdGPWRxvKXCnMyT6qFPZb
</commit_message>
<xml_diff>
--- a/presentation/SAR_Security_Program_Presentation.pptx
+++ b/presentation/SAR_Security_Program_Presentation.pptx
@@ -8,9 +8,11 @@
     <p:sldId id="256" r:id="rId2"/>
     <p:sldId id="257" r:id="rId3"/>
     <p:sldId id="258" r:id="rId4"/>
+    <p:sldId id="259" r:id="rId5"/>
+    <p:sldId id="260" r:id="rId6"/>
   </p:sldIdLst>
   <p:notesMasterIdLst>
-    <p:notesMasterId r:id="rId5"/>
+    <p:notesMasterId r:id="rId7"/>
   </p:notesMasterIdLst>
   <p:sldSz cx="12192000" cy="6858000"/>
   <p:notesSz cx="6858000" cy="12192000"/>
@@ -1554,7 +1556,7 @@
           <a:p>
             <a:r>
               <a:rPr lang="en-US" dirty="0"/>
-              <a:t>Source: draft contract between SAR and ETECHS (22 Jan 2024) with Annexes 1 to 5. Station list: Annex 1 deliverables. Quantities and sub-systems: Annex 3 price table (Revised-02, SAR 62,000,000 ex-VAT; EWR 11,113,215, NSR 20,499,295, HHR 30,387,490). Boundaries: Annex 3 terms (exclusions) and Annex 5 SAR responses (inner areas only). Madinah is priced at 50% of the Makkah BOQ.</a:t>
+              <a:t>Cover. Prepared for Saudi Arabia Railways (SAR) from the draft SAR and ETECHS contract and its annexes.</a:t>
             </a:r>
             <a:endParaRPr lang="en-US" dirty="0"/>
           </a:p>
@@ -1642,7 +1644,7 @@
           <a:p>
             <a:r>
               <a:rPr lang="en-US" dirty="0"/>
-              <a:t>Contract facts: 36-month term from Notice to Proceed (Annex 1); initial baseline within 10 days of the effective date, detailed baseline 21 days after the mobilization and survey works, SAR review at most 21 days (clause 3, Baseline Programme); trial operation maximum 45 days; defects liability 1 year from each Taking-Over Certificate. Everything else is a planning assumption: Riyadh starts in weeks 6 and 8 with expedited procurement; other stations are spread so the last final acceptance falls at month 36; NTP 1 Nov 2026 is an editable assumption. Level 3 and 4 detail is in the interactive dashboard.</a:t>
+              <a:t>Source: draft contract between SAR and ETECHS (22 Jan 2024) with Annexes 1 to 5. Station list: Annex 1 deliverables. Quantities and sub-systems: Annex 3 price table (Revised-02, SAR 62,000,000 ex-VAT; EWR 11,113,215, NSR 20,499,295, HHR 30,387,490). Boundaries: Annex 3 terms (exclusions) and Annex 5 SAR responses (inner areas only). Madinah is priced at 50% of the Makkah BOQ.</a:t>
             </a:r>
             <a:endParaRPr lang="en-US" dirty="0"/>
           </a:p>
@@ -1730,6 +1732,94 @@
           <a:p>
             <a:r>
               <a:rPr lang="en-US" dirty="0"/>
+              <a:t>Contract facts: 36-month term from Notice to Proceed (Annex 1); initial baseline within 10 days of the effective date, detailed baseline 21 days after the mobilization and survey works, SAR review at most 21 days (clause 3, Baseline Programme); trial operation maximum 45 days; defects liability 1 year from each Taking-Over Certificate. Everything else is a planning assumption: Riyadh starts in weeks 6 and 8 with expedited procurement; other stations are spread so the last final acceptance falls at month 36; NTP 1 Nov 2026 is an editable assumption. Level 3 and 4 detail is in the interactive dashboard.</a:t>
+            </a:r>
+            <a:endParaRPr lang="en-US" dirty="0"/>
+          </a:p>
+        </p:txBody>
+      </p:sp>
+      <p:sp>
+        <p:nvSpPr>
+          <p:cNvPr id="4" name="Slide Number Placeholder 3"/>
+          <p:cNvSpPr>
+            <a:spLocks noGrp="1"/>
+          </p:cNvSpPr>
+          <p:nvPr>
+            <p:ph type="sldNum" sz="quarter" idx="10"/>
+          </p:nvPr>
+        </p:nvSpPr>
+        <p:spPr/>
+        <p:txBody>
+          <a:bodyPr/>
+          <a:lstStyle/>
+          <a:p>
+            <a:fld id="{F7021451-1387-4CA6-816F-3879F97B5CBC}" type="slidenum">
+              <a:rPr lang="en-US"/>
+              <a:t>3</a:t>
+            </a:fld>
+            <a:endParaRPr lang="en-US"/>
+          </a:p>
+        </p:txBody>
+      </p:sp>
+    </p:spTree>
+    <p:extLst>
+      <p:ext uri="{BB962C8B-B14F-4D97-AF65-F5344CB8AC3E}">
+        <p14:creationId xmlns:p14="http://schemas.microsoft.com/office/powerpoint/2010/main" val="1024086991"/>
+      </p:ext>
+    </p:extLst>
+  </p:cSld>
+  <p:clrMapOvr>
+    <a:masterClrMapping/>
+  </p:clrMapOvr>
+</p:notes>
+</file>
+
+<file path=ppt/notesSlides/notesSlide4.xml><?xml version="1.0" encoding="utf-8"?>
+<p:notes xmlns:a="http://schemas.openxmlformats.org/drawingml/2006/main" xmlns:r="http://schemas.openxmlformats.org/officeDocument/2006/relationships" xmlns:p="http://schemas.openxmlformats.org/presentationml/2006/main">
+  <p:cSld>
+    <p:spTree>
+      <p:nvGrpSpPr>
+        <p:cNvPr id="1" name=""/>
+        <p:cNvGrpSpPr/>
+        <p:nvPr/>
+      </p:nvGrpSpPr>
+      <p:grpSpPr>
+        <a:xfrm>
+          <a:off x="0" y="0"/>
+          <a:ext cx="0" cy="0"/>
+          <a:chOff x="0" y="0"/>
+          <a:chExt cx="0" cy="0"/>
+        </a:xfrm>
+      </p:grpSpPr>
+      <p:sp>
+        <p:nvSpPr>
+          <p:cNvPr id="2" name="Slide Image Placeholder 1"/>
+          <p:cNvSpPr>
+            <a:spLocks noGrp="1" noRot="1" noChangeAspect="1"/>
+          </p:cNvSpPr>
+          <p:nvPr>
+            <p:ph type="sldImg"/>
+          </p:nvPr>
+        </p:nvSpPr>
+        <p:spPr/>
+      </p:sp>
+      <p:sp>
+        <p:nvSpPr>
+          <p:cNvPr id="3" name="Notes Placeholder 2"/>
+          <p:cNvSpPr>
+            <a:spLocks noGrp="1"/>
+          </p:cNvSpPr>
+          <p:nvPr>
+            <p:ph type="body" idx="1"/>
+          </p:nvPr>
+        </p:nvSpPr>
+        <p:spPr/>
+        <p:txBody>
+          <a:bodyPr/>
+          <a:lstStyle/>
+          <a:p>
+            <a:r>
+              <a:rPr lang="en-US" dirty="0"/>
               <a:t>Monthly amounts are the invoices falling in each month, from clause 15 of the draft contract: 20% mobilization, 10% engineering submittal, 10% after SAR approval, 20% material delivery, 20% installation, 10% testing and commissioning (SAT), 10% final acceptance and handover, each prorated per station on the station value. Invoice dates follow the planning baseline on the schedule slide (assumed, not approved by SAR). Month 1 is the first month after the Notice to Proceed (1 Nov 2026 assumed). Amounts exclude 15% VAT.</a:t>
             </a:r>
             <a:endParaRPr lang="en-US" dirty="0"/>
@@ -1753,7 +1843,95 @@
           <a:p>
             <a:fld id="{F7021451-1387-4CA6-816F-3879F97B5CBC}" type="slidenum">
               <a:rPr lang="en-US"/>
-              <a:t>3</a:t>
+              <a:t>4</a:t>
+            </a:fld>
+            <a:endParaRPr lang="en-US"/>
+          </a:p>
+        </p:txBody>
+      </p:sp>
+    </p:spTree>
+    <p:extLst>
+      <p:ext uri="{BB962C8B-B14F-4D97-AF65-F5344CB8AC3E}">
+        <p14:creationId xmlns:p14="http://schemas.microsoft.com/office/powerpoint/2010/main" val="1024086991"/>
+      </p:ext>
+    </p:extLst>
+  </p:cSld>
+  <p:clrMapOvr>
+    <a:masterClrMapping/>
+  </p:clrMapOvr>
+</p:notes>
+</file>
+
+<file path=ppt/notesSlides/notesSlide5.xml><?xml version="1.0" encoding="utf-8"?>
+<p:notes xmlns:a="http://schemas.openxmlformats.org/drawingml/2006/main" xmlns:r="http://schemas.openxmlformats.org/officeDocument/2006/relationships" xmlns:p="http://schemas.openxmlformats.org/presentationml/2006/main">
+  <p:cSld>
+    <p:spTree>
+      <p:nvGrpSpPr>
+        <p:cNvPr id="1" name=""/>
+        <p:cNvGrpSpPr/>
+        <p:nvPr/>
+      </p:nvGrpSpPr>
+      <p:grpSpPr>
+        <a:xfrm>
+          <a:off x="0" y="0"/>
+          <a:ext cx="0" cy="0"/>
+          <a:chOff x="0" y="0"/>
+          <a:chExt cx="0" cy="0"/>
+        </a:xfrm>
+      </p:grpSpPr>
+      <p:sp>
+        <p:nvSpPr>
+          <p:cNvPr id="2" name="Slide Image Placeholder 1"/>
+          <p:cNvSpPr>
+            <a:spLocks noGrp="1" noRot="1" noChangeAspect="1"/>
+          </p:cNvSpPr>
+          <p:nvPr>
+            <p:ph type="sldImg"/>
+          </p:nvPr>
+        </p:nvSpPr>
+        <p:spPr/>
+      </p:sp>
+      <p:sp>
+        <p:nvSpPr>
+          <p:cNvPr id="3" name="Notes Placeholder 2"/>
+          <p:cNvSpPr>
+            <a:spLocks noGrp="1"/>
+          </p:cNvSpPr>
+          <p:nvPr>
+            <p:ph type="body" idx="1"/>
+          </p:nvPr>
+        </p:nvSpPr>
+        <p:spPr/>
+        <p:txBody>
+          <a:bodyPr/>
+          <a:lstStyle/>
+          <a:p>
+            <a:r>
+              <a:rPr lang="en-US" dirty="0"/>
+              <a:t>Closing slide. All figures are from the draft contract and its annexes; schedule dates are a planning baseline, not approved by SAR.</a:t>
+            </a:r>
+            <a:endParaRPr lang="en-US" dirty="0"/>
+          </a:p>
+        </p:txBody>
+      </p:sp>
+      <p:sp>
+        <p:nvSpPr>
+          <p:cNvPr id="4" name="Slide Number Placeholder 3"/>
+          <p:cNvSpPr>
+            <a:spLocks noGrp="1"/>
+          </p:cNvSpPr>
+          <p:nvPr>
+            <p:ph type="sldNum" sz="quarter" idx="10"/>
+          </p:nvPr>
+        </p:nvSpPr>
+        <p:spPr/>
+        <p:txBody>
+          <a:bodyPr/>
+          <a:lstStyle/>
+          <a:p>
+            <a:fld id="{F7021451-1387-4CA6-816F-3879F97B5CBC}" type="slidenum">
+              <a:rPr lang="en-US"/>
+              <a:t>5</a:t>
             </a:fld>
             <a:endParaRPr lang="en-US"/>
           </a:p>
@@ -2096,6 +2274,261 @@
           <a:chExt cx="0" cy="0"/>
         </a:xfrm>
       </p:grpSpPr>
+      <p:sp>
+        <p:nvSpPr>
+          <p:cNvPr id="2" name="Shape 0"/>
+          <p:cNvSpPr/>
+          <p:nvPr/>
+        </p:nvSpPr>
+        <p:spPr>
+          <a:xfrm>
+            <a:off x="1842516" y="3291840"/>
+            <a:ext cx="502920" cy="3566160"/>
+          </a:xfrm>
+          <a:prstGeom prst="parallelogram">
+            <a:avLst/>
+          </a:prstGeom>
+          <a:solidFill>
+            <a:srgbClr val="00778B"/>
+          </a:solidFill>
+          <a:ln w="12700">
+            <a:solidFill>
+              <a:srgbClr val="00778B"/>
+            </a:solidFill>
+            <a:prstDash val="solid"/>
+          </a:ln>
+        </p:spPr>
+      </p:sp>
+      <p:sp>
+        <p:nvSpPr>
+          <p:cNvPr id="3" name="Shape 1"/>
+          <p:cNvSpPr/>
+          <p:nvPr/>
+        </p:nvSpPr>
+        <p:spPr>
+          <a:xfrm flipH="1">
+            <a:off x="9843516" y="3291840"/>
+            <a:ext cx="502920" cy="3566160"/>
+          </a:xfrm>
+          <a:prstGeom prst="parallelogram">
+            <a:avLst/>
+          </a:prstGeom>
+          <a:solidFill>
+            <a:srgbClr val="00778B"/>
+          </a:solidFill>
+          <a:ln w="12700">
+            <a:solidFill>
+              <a:srgbClr val="00778B"/>
+            </a:solidFill>
+            <a:prstDash val="solid"/>
+          </a:ln>
+        </p:spPr>
+      </p:sp>
+      <p:pic>
+        <p:nvPicPr>
+          <p:cNvPr id="4" name="Image 0" descr="preencoded.png">    </p:cNvPr>
+          <p:cNvPicPr>
+            <a:picLocks noChangeAspect="1"/>
+          </p:cNvPicPr>
+          <p:nvPr/>
+        </p:nvPicPr>
+        <p:blipFill>
+          <a:blip r:embed="rId1"/>
+          <a:stretch>
+            <a:fillRect/>
+          </a:stretch>
+        </p:blipFill>
+        <p:spPr>
+          <a:xfrm>
+            <a:off x="5639105" y="502920"/>
+            <a:ext cx="910742" cy="566928"/>
+          </a:xfrm>
+          <a:prstGeom prst="rect">
+            <a:avLst/>
+          </a:prstGeom>
+        </p:spPr>
+      </p:pic>
+      <p:sp>
+        <p:nvSpPr>
+          <p:cNvPr id="5" name="Text 2"/>
+          <p:cNvSpPr/>
+          <p:nvPr/>
+        </p:nvSpPr>
+        <p:spPr>
+          <a:xfrm>
+            <a:off x="1280160" y="1417320"/>
+            <a:ext cx="9601200" cy="685800"/>
+          </a:xfrm>
+          <a:prstGeom prst="rect">
+            <a:avLst/>
+          </a:prstGeom>
+          <a:noFill/>
+          <a:ln/>
+        </p:spPr>
+        <p:txBody>
+          <a:bodyPr wrap="square" lIns="0" tIns="0" rIns="0" bIns="0" rtlCol="0" anchor="ctr"/>
+          <a:lstStyle/>
+          <a:p>
+            <a:pPr algn="ctr" indent="0" marL="0">
+              <a:buNone/>
+            </a:pPr>
+            <a:r>
+              <a:rPr lang="en-US" sz="3200" b="1" dirty="0">
+                <a:solidFill>
+                  <a:srgbClr val="00778B"/>
+                </a:solidFill>
+                <a:latin typeface="Diodrum Arabic" pitchFamily="34" charset="0"/>
+                <a:ea typeface="Diodrum Arabic" pitchFamily="34" charset="-122"/>
+                <a:cs typeface="Diodrum Arabic" pitchFamily="34" charset="-120"/>
+              </a:rPr>
+              <a:t>Passengers' Security Checking</a:t>
+            </a:r>
+            <a:endParaRPr lang="en-US" sz="3200" dirty="0"/>
+          </a:p>
+        </p:txBody>
+      </p:sp>
+      <p:sp>
+        <p:nvSpPr>
+          <p:cNvPr id="6" name="Text 3"/>
+          <p:cNvSpPr/>
+          <p:nvPr/>
+        </p:nvSpPr>
+        <p:spPr>
+          <a:xfrm>
+            <a:off x="1280160" y="2121408"/>
+            <a:ext cx="9601200" cy="365760"/>
+          </a:xfrm>
+          <a:prstGeom prst="rect">
+            <a:avLst/>
+          </a:prstGeom>
+          <a:noFill/>
+          <a:ln/>
+        </p:spPr>
+        <p:txBody>
+          <a:bodyPr wrap="square" lIns="0" tIns="0" rIns="0" bIns="0" rtlCol="0" anchor="ctr"/>
+          <a:lstStyle/>
+          <a:p>
+            <a:pPr algn="ctr" indent="0" marL="0">
+              <a:buNone/>
+            </a:pPr>
+            <a:r>
+              <a:rPr lang="en-US" sz="2200" dirty="0">
+                <a:solidFill>
+                  <a:srgbClr val="768692"/>
+                </a:solidFill>
+                <a:latin typeface="Diodrum Arabic" pitchFamily="34" charset="0"/>
+                <a:ea typeface="Diodrum Arabic" pitchFamily="34" charset="-122"/>
+                <a:cs typeface="Diodrum Arabic" pitchFamily="34" charset="-120"/>
+              </a:rPr>
+              <a:t>Scope of work, Level 2 schedule and cash flow</a:t>
+            </a:r>
+            <a:endParaRPr lang="en-US" sz="2200" dirty="0"/>
+          </a:p>
+        </p:txBody>
+      </p:sp>
+      <p:sp>
+        <p:nvSpPr>
+          <p:cNvPr id="7" name="Text 4"/>
+          <p:cNvSpPr/>
+          <p:nvPr/>
+        </p:nvSpPr>
+        <p:spPr>
+          <a:xfrm>
+            <a:off x="1280160" y="2560320"/>
+            <a:ext cx="9601200" cy="274320"/>
+          </a:xfrm>
+          <a:prstGeom prst="rect">
+            <a:avLst/>
+          </a:prstGeom>
+          <a:noFill/>
+          <a:ln/>
+        </p:spPr>
+        <p:txBody>
+          <a:bodyPr wrap="square" lIns="0" tIns="0" rIns="0" bIns="0" rtlCol="0" anchor="ctr"/>
+          <a:lstStyle/>
+          <a:p>
+            <a:pPr algn="ctr" indent="0" marL="0">
+              <a:buNone/>
+            </a:pPr>
+            <a:r>
+              <a:rPr lang="en-US" sz="1100" dirty="0">
+                <a:solidFill>
+                  <a:srgbClr val="3D3935"/>
+                </a:solidFill>
+                <a:latin typeface="Diodrum Arabic" pitchFamily="34" charset="0"/>
+                <a:ea typeface="Diodrum Arabic" pitchFamily="34" charset="-122"/>
+                <a:cs typeface="Diodrum Arabic" pitchFamily="34" charset="-120"/>
+              </a:rPr>
+              <a:t>Security solutions for HHR, EWR and NSR  ·  14 stations  ·  SAR 62.0M  ·  36 months  |  October 2026</a:t>
+            </a:r>
+            <a:endParaRPr lang="en-US" sz="1100" dirty="0"/>
+          </a:p>
+        </p:txBody>
+      </p:sp>
+      <p:sp>
+        <p:nvSpPr>
+          <p:cNvPr id="8" name="Text 5"/>
+          <p:cNvSpPr/>
+          <p:nvPr/>
+        </p:nvSpPr>
+        <p:spPr>
+          <a:xfrm>
+            <a:off x="8778240" y="6355080"/>
+            <a:ext cx="3017520" cy="274320"/>
+          </a:xfrm>
+          <a:prstGeom prst="rect">
+            <a:avLst/>
+          </a:prstGeom>
+          <a:noFill/>
+          <a:ln/>
+        </p:spPr>
+        <p:txBody>
+          <a:bodyPr wrap="square" lIns="0" tIns="0" rIns="0" bIns="0" rtlCol="0" anchor="ctr"/>
+          <a:lstStyle/>
+          <a:p>
+            <a:pPr algn="r" indent="0" marL="0">
+              <a:buNone/>
+            </a:pPr>
+            <a:r>
+              <a:rPr lang="en-US" sz="900" b="1" dirty="0">
+                <a:solidFill>
+                  <a:srgbClr val="FFFFFF"/>
+                </a:solidFill>
+                <a:latin typeface="Diodrum Arabic" pitchFamily="34" charset="0"/>
+                <a:ea typeface="Diodrum Arabic" pitchFamily="34" charset="-122"/>
+                <a:cs typeface="Diodrum Arabic" pitchFamily="34" charset="-120"/>
+              </a:rPr>
+              <a:t>SAR.COM.SA</a:t>
+            </a:r>
+            <a:endParaRPr lang="en-US" sz="900" dirty="0"/>
+          </a:p>
+        </p:txBody>
+      </p:sp>
+    </p:spTree>
+  </p:cSld>
+  <p:clrMapOvr>
+    <a:masterClrMapping/>
+  </p:clrMapOvr>
+</p:sld>
+</file>
+
+<file path=ppt/slides/slide2.xml><?xml version="1.0" encoding="utf-8"?>
+<p:sld xmlns:a="http://schemas.openxmlformats.org/drawingml/2006/main" xmlns:r="http://schemas.openxmlformats.org/officeDocument/2006/relationships" xmlns:p="http://schemas.openxmlformats.org/presentationml/2006/main">
+  <p:cSld name="Slide 2">
+    <p:spTree>
+      <p:nvGrpSpPr>
+        <p:cNvPr id="1" name=""/>
+        <p:cNvGrpSpPr/>
+        <p:nvPr/>
+      </p:nvGrpSpPr>
+      <p:grpSpPr>
+        <a:xfrm>
+          <a:off x="0" y="0"/>
+          <a:ext cx="0" cy="0"/>
+          <a:chOff x="0" y="0"/>
+          <a:chExt cx="0" cy="0"/>
+        </a:xfrm>
+      </p:grpSpPr>
       <p:pic>
         <p:nvPicPr>
           <p:cNvPr id="2" name="Image 0" descr="preencoded.png">    </p:cNvPr>
@@ -2192,7 +2625,7 @@
                 <a:ea typeface="Diodrum Arabic" pitchFamily="34" charset="-122"/>
                 <a:cs typeface="Diodrum Arabic" pitchFamily="34" charset="-120"/>
               </a:rPr>
-              <a:t>1</a:t>
+              <a:t>2</a:t>
             </a:r>
             <a:endParaRPr lang="en-US" sz="900" dirty="0"/>
           </a:p>
@@ -4054,9 +4487,9 @@
 </p:sld>
 </file>
 
-<file path=ppt/slides/slide2.xml><?xml version="1.0" encoding="utf-8"?>
+<file path=ppt/slides/slide3.xml><?xml version="1.0" encoding="utf-8"?>
 <p:sld xmlns:a="http://schemas.openxmlformats.org/drawingml/2006/main" xmlns:r="http://schemas.openxmlformats.org/officeDocument/2006/relationships" xmlns:p="http://schemas.openxmlformats.org/presentationml/2006/main">
-  <p:cSld name="Slide 2">
+  <p:cSld name="Slide 3">
     <p:spTree>
       <p:nvGrpSpPr>
         <p:cNvPr id="1" name=""/>
@@ -4167,7 +4600,7 @@
                 <a:ea typeface="Diodrum Arabic" pitchFamily="34" charset="-122"/>
                 <a:cs typeface="Diodrum Arabic" pitchFamily="34" charset="-120"/>
               </a:rPr>
-              <a:t>2</a:t>
+              <a:t>3</a:t>
             </a:r>
             <a:endParaRPr lang="en-US" sz="900" dirty="0"/>
           </a:p>
@@ -7378,9 +7811,9 @@
 </p:sld>
 </file>
 
-<file path=ppt/slides/slide3.xml><?xml version="1.0" encoding="utf-8"?>
+<file path=ppt/slides/slide4.xml><?xml version="1.0" encoding="utf-8"?>
 <p:sld xmlns:a="http://schemas.openxmlformats.org/drawingml/2006/main" xmlns:r="http://schemas.openxmlformats.org/officeDocument/2006/relationships" xmlns:p="http://schemas.openxmlformats.org/presentationml/2006/main">
-  <p:cSld name="Slide 3">
+  <p:cSld name="Slide 4">
     <p:spTree>
       <p:nvGrpSpPr>
         <p:cNvPr id="1" name=""/>
@@ -7491,7 +7924,7 @@
                 <a:ea typeface="Diodrum Arabic" pitchFamily="34" charset="-122"/>
                 <a:cs typeface="Diodrum Arabic" pitchFamily="34" charset="-120"/>
               </a:rPr>
-              <a:t>3</a:t>
+              <a:t>4</a:t>
             </a:r>
             <a:endParaRPr lang="en-US" sz="900" dirty="0"/>
           </a:p>
@@ -7650,7 +8083,7 @@
       </p:sp>
       <p:graphicFrame>
         <p:nvGraphicFramePr>
-          <p:cNvPr id="4" name="Table 0"/>
+          <p:cNvPr id="5" name="Table 0"/>
           <p:cNvGraphicFramePr>
             <a:graphicFrameLocks noGrp="1"/>
           </p:cNvGraphicFramePr>
@@ -16437,7 +16870,7 @@
       </p:graphicFrame>
       <p:graphicFrame>
         <p:nvGraphicFramePr>
-          <p:cNvPr id="7" name="Table 1"/>
+          <p:cNvPr id="9" name="Table 1"/>
           <p:cNvGraphicFramePr>
             <a:graphicFrameLocks noGrp="1"/>
           </p:cNvGraphicFramePr>
@@ -18922,6 +19355,190 @@
           </a:graphicData>
         </a:graphic>
       </p:graphicFrame>
+    </p:spTree>
+  </p:cSld>
+  <p:clrMapOvr>
+    <a:masterClrMapping/>
+  </p:clrMapOvr>
+</p:sld>
+</file>
+
+<file path=ppt/slides/slide5.xml><?xml version="1.0" encoding="utf-8"?>
+<p:sld xmlns:a="http://schemas.openxmlformats.org/drawingml/2006/main" xmlns:r="http://schemas.openxmlformats.org/officeDocument/2006/relationships" xmlns:p="http://schemas.openxmlformats.org/presentationml/2006/main">
+  <p:cSld name="Slide 5">
+    <p:bg>
+      <p:bgPr>
+        <a:solidFill>
+          <a:srgbClr val="00778B"/>
+        </a:solidFill>
+      </p:bgPr>
+    </p:bg>
+    <p:spTree>
+      <p:nvGrpSpPr>
+        <p:cNvPr id="1" name=""/>
+        <p:cNvGrpSpPr/>
+        <p:nvPr/>
+      </p:nvGrpSpPr>
+      <p:grpSpPr>
+        <a:xfrm>
+          <a:off x="0" y="0"/>
+          <a:ext cx="0" cy="0"/>
+          <a:chOff x="0" y="0"/>
+          <a:chExt cx="0" cy="0"/>
+        </a:xfrm>
+      </p:grpSpPr>
+      <p:sp>
+        <p:nvSpPr>
+          <p:cNvPr id="2" name="Shape 0"/>
+          <p:cNvSpPr/>
+          <p:nvPr/>
+        </p:nvSpPr>
+        <p:spPr>
+          <a:xfrm>
+            <a:off x="3534156" y="3246120"/>
+            <a:ext cx="914400" cy="3611880"/>
+          </a:xfrm>
+          <a:prstGeom prst="parallelogram">
+            <a:avLst/>
+          </a:prstGeom>
+          <a:solidFill>
+            <a:srgbClr val="FFFFFF"/>
+          </a:solidFill>
+          <a:ln w="12700">
+            <a:solidFill>
+              <a:srgbClr val="FFFFFF"/>
+            </a:solidFill>
+            <a:prstDash val="solid"/>
+          </a:ln>
+        </p:spPr>
+      </p:sp>
+      <p:sp>
+        <p:nvSpPr>
+          <p:cNvPr id="3" name="Shape 1"/>
+          <p:cNvSpPr/>
+          <p:nvPr/>
+        </p:nvSpPr>
+        <p:spPr>
+          <a:xfrm flipH="1">
+            <a:off x="7740396" y="3246120"/>
+            <a:ext cx="914400" cy="3611880"/>
+          </a:xfrm>
+          <a:prstGeom prst="parallelogram">
+            <a:avLst/>
+          </a:prstGeom>
+          <a:solidFill>
+            <a:srgbClr val="FFFFFF"/>
+          </a:solidFill>
+          <a:ln w="12700">
+            <a:solidFill>
+              <a:srgbClr val="FFFFFF"/>
+            </a:solidFill>
+            <a:prstDash val="solid"/>
+          </a:ln>
+        </p:spPr>
+      </p:sp>
+      <p:pic>
+        <p:nvPicPr>
+          <p:cNvPr id="4" name="Image 0" descr="preencoded.png">    </p:cNvPr>
+          <p:cNvPicPr>
+            <a:picLocks noChangeAspect="1"/>
+          </p:cNvPicPr>
+          <p:nvPr/>
+        </p:nvPicPr>
+        <p:blipFill>
+          <a:blip r:embed="rId1"/>
+          <a:stretch>
+            <a:fillRect/>
+          </a:stretch>
+        </p:blipFill>
+        <p:spPr>
+          <a:xfrm>
+            <a:off x="5690311" y="4160520"/>
+            <a:ext cx="808330" cy="502920"/>
+          </a:xfrm>
+          <a:prstGeom prst="rect">
+            <a:avLst/>
+          </a:prstGeom>
+        </p:spPr>
+      </p:pic>
+      <p:sp>
+        <p:nvSpPr>
+          <p:cNvPr id="5" name="Text 2"/>
+          <p:cNvSpPr/>
+          <p:nvPr/>
+        </p:nvSpPr>
+        <p:spPr>
+          <a:xfrm>
+            <a:off x="0" y="1965960"/>
+            <a:ext cx="12188952" cy="822960"/>
+          </a:xfrm>
+          <a:prstGeom prst="rect">
+            <a:avLst/>
+          </a:prstGeom>
+          <a:noFill/>
+          <a:ln/>
+        </p:spPr>
+        <p:txBody>
+          <a:bodyPr wrap="square" lIns="0" tIns="0" rIns="0" bIns="0" rtlCol="0" anchor="ctr"/>
+          <a:lstStyle/>
+          <a:p>
+            <a:pPr algn="ctr" indent="0" marL="0">
+              <a:buNone/>
+            </a:pPr>
+            <a:r>
+              <a:rPr lang="en-US" sz="3600" b="1" dirty="0">
+                <a:solidFill>
+                  <a:srgbClr val="FFFFFF"/>
+                </a:solidFill>
+                <a:latin typeface="Diodrum Arabic" pitchFamily="34" charset="0"/>
+                <a:ea typeface="Diodrum Arabic" pitchFamily="34" charset="-122"/>
+                <a:cs typeface="Diodrum Arabic" pitchFamily="34" charset="-120"/>
+              </a:rPr>
+              <a:t>Thank You</a:t>
+            </a:r>
+            <a:endParaRPr lang="en-US" sz="3600" dirty="0"/>
+          </a:p>
+        </p:txBody>
+      </p:sp>
+      <p:sp>
+        <p:nvSpPr>
+          <p:cNvPr id="6" name="Text 3"/>
+          <p:cNvSpPr/>
+          <p:nvPr/>
+        </p:nvSpPr>
+        <p:spPr>
+          <a:xfrm>
+            <a:off x="0" y="6172200"/>
+            <a:ext cx="12188952" cy="274320"/>
+          </a:xfrm>
+          <a:prstGeom prst="rect">
+            <a:avLst/>
+          </a:prstGeom>
+          <a:noFill/>
+          <a:ln/>
+        </p:spPr>
+        <p:txBody>
+          <a:bodyPr wrap="square" lIns="0" tIns="0" rIns="0" bIns="0" rtlCol="0" anchor="ctr"/>
+          <a:lstStyle/>
+          <a:p>
+            <a:pPr algn="ctr" indent="0" marL="0">
+              <a:buNone/>
+            </a:pPr>
+            <a:r>
+              <a:rPr lang="en-US" sz="900" dirty="0">
+                <a:solidFill>
+                  <a:srgbClr val="FFFFFF"/>
+                </a:solidFill>
+                <a:latin typeface="Diodrum Arabic" pitchFamily="34" charset="0"/>
+                <a:ea typeface="Diodrum Arabic" pitchFamily="34" charset="-122"/>
+                <a:cs typeface="Diodrum Arabic" pitchFamily="34" charset="-120"/>
+              </a:rPr>
+              <a:t>SAR.COM.SA</a:t>
+            </a:r>
+            <a:endParaRPr lang="en-US" sz="900" dirty="0"/>
+          </a:p>
+        </p:txBody>
+      </p:sp>
     </p:spTree>
   </p:cSld>
   <p:clrMapOvr>

</xml_diff>

<commit_message>
Fix annex numbering (Annex 4 = Clarifications, Annex 5 = Compliance Table); soften fast-track wording; point Publish link to this repo
Co-Authored-By: Claude Sonnet 5.5 <noreply@anthropic.com>
Claude-Session: https://claude.ai/code/session_01DZdGPWRxvKXCnMyT6qFPZb
</commit_message>
<xml_diff>
--- a/presentation/SAR_Security_Program_Presentation.pptx
+++ b/presentation/SAR_Security_Program_Presentation.pptx
@@ -1940,7 +1940,7 @@
           <a:p>
             <a:r>
               <a:rPr lang="en-US" dirty="0"/>
-              <a:t>Source: draft contract between SAR and ETECHS (22 Jan 2024) with Annexes 1 to 5. Station list: Annex 1 deliverables. Quantities and sub-systems: Annex 3 price table (Revised-02, SAR 62,000,000 ex-VAT; EWR 11,113,215, NSR 20,499,295, HHR 30,387,490). Boundaries: Annex 3 terms (exclusions) and Annex 5 SAR responses (inner areas only). Madinah is priced at 50% of the Makkah BOQ.</a:t>
+              <a:t>Source: draft contract between SAR and ETECHS (22 Jan 2024) with Annexes 1 to 5. Station list: Annex 1 deliverables. Quantities and sub-systems: Annex 3 price table (Revised-02, SAR 62,000,000 ex-VAT; EWR 11,113,215, NSR 20,499,295, HHR 30,387,490). Boundaries: Annex 3 terms (exclusions) and Annex 4 SAR responses (inner areas only, item 12). Madinah is priced at 50% of the Makkah BOQ.</a:t>
             </a:r>
             <a:endParaRPr lang="en-US" dirty="0"/>
           </a:p>
@@ -2116,7 +2116,7 @@
           <a:p>
             <a:r>
               <a:rPr lang="en-US" dirty="0"/>
-              <a:t>Sources: contract clauses 3 (Baseline Programme), 10 (time for performance), 15 (payments), acceptance and defects liability clauses; Annex 2 clauses 3, 5, 6, 9 to 13; Annex 3 terms (exclusions, FAT, delivery, warranty); Annex 5 (SAR responses: inner areas only, fast-track project, laydown area, integration conditions). Trial operation is defined in the contract as a maximum of 45 days.</a:t>
+              <a:t>Sources: contract clauses 3 (Baseline Programme), 10 (time for performance), 15 (payments), acceptance and defects liability clauses; Annex 2 clauses 3, 5, 6, 9 to 13; Annex 3 terms (exclusions, FAT, delivery, warranty); Annex 4 (clarifications: SAR responses on inner areas only, item 12; fast-track, item 33; laydown area; integration conditions). Annex 5 is the compliance table (HCIS Stage 3 approval, training, spares, lump sum). Trial operation is defined in the contract as a maximum of 45 days.</a:t>
             </a:r>
             <a:endParaRPr lang="en-US" dirty="0"/>
           </a:p>
@@ -4860,7 +4860,7 @@
                 <a:ea typeface="Diodrum Arabic" pitchFamily="34" charset="-122"/>
                 <a:cs typeface="Diodrum Arabic" pitchFamily="34" charset="-120"/>
               </a:rPr>
-              <a:t>BOUNDARIES (ANNEXES 3 AND 5)</a:t>
+              <a:t>BOUNDARIES (ANNEXES 3 AND 4)</a:t>
             </a:r>
             <a:endParaRPr lang="en-US" sz="1100" dirty="0"/>
           </a:p>
@@ -11615,7 +11615,7 @@
                 <a:ea typeface="Diodrum Arabic" pitchFamily="34" charset="-122"/>
                 <a:cs typeface="Diodrum Arabic" pitchFamily="34" charset="-120"/>
               </a:rPr>
-              <a:t>From the contract body, Annex 2 (SAR Scope of Work), Annex 3 terms and Annex 5 clarifications</a:t>
+              <a:t>From the contract body, Annex 2 (SAR Scope of Work), Annex 3 terms and Annex 4 clarifications</a:t>
             </a:r>
             <a:endParaRPr lang="en-US" sz="1200" dirty="0"/>
           </a:p>
@@ -12379,7 +12379,7 @@
                 <a:ea typeface="Diodrum Arabic" pitchFamily="34" charset="-122"/>
                 <a:cs typeface="Diodrum Arabic" pitchFamily="34" charset="-120"/>
               </a:rPr>
-              <a:t>Fast-track, no HCIS Stage 1 or 2; Madinah at 50%</a:t>
+              <a:t>Fast-track project (Annex 4, item 33); Madinah at 50%</a:t>
             </a:r>
             <a:endParaRPr lang="en-US" sz="1100" dirty="0"/>
           </a:p>

</xml_diff>